<commit_message>
Finalize Demo 1 submission wording
</commit_message>
<xml_diff>
--- a/slides/demo-1.pptx
+++ b/slides/demo-1.pptx
@@ -2,20 +2,20 @@
 <file path=ppt/presentation.xml><?xml version="1.0" encoding="utf-8"?>
 <p:presentation xmlns:p="http://schemas.openxmlformats.org/presentationml/2006/main">
   <p:sldMasterIdLst>
-    <p:sldMasterId xmlns:r="http://schemas.openxmlformats.org/officeDocument/2006/relationships" id="2147483648" r:id="R221aff6ef20541a9"/>
+    <p:sldMasterId xmlns:r="http://schemas.openxmlformats.org/officeDocument/2006/relationships" id="2147483648" r:id="Re0c68cff40774ddb"/>
   </p:sldMasterIdLst>
   <p:notesMasterIdLst>
-    <p:notesMasterId xmlns:r="http://schemas.openxmlformats.org/officeDocument/2006/relationships" r:id="R99f151390ea9444d"/>
+    <p:notesMasterId xmlns:r="http://schemas.openxmlformats.org/officeDocument/2006/relationships" r:id="Rce8af401aa51415c"/>
   </p:notesMasterIdLst>
   <p:sldIdLst>
-    <p:sldId xmlns:r="http://schemas.openxmlformats.org/officeDocument/2006/relationships" id="256" r:id="Rd25e0a12a68b4ef9"/>
-    <p:sldId xmlns:r="http://schemas.openxmlformats.org/officeDocument/2006/relationships" id="257" r:id="Rcc7490f8588942a1"/>
-    <p:sldId xmlns:r="http://schemas.openxmlformats.org/officeDocument/2006/relationships" id="258" r:id="R372401555a644a8c"/>
-    <p:sldId xmlns:r="http://schemas.openxmlformats.org/officeDocument/2006/relationships" id="259" r:id="Rd4899f324b294804"/>
-    <p:sldId xmlns:r="http://schemas.openxmlformats.org/officeDocument/2006/relationships" id="260" r:id="R8f4599bef69d4e30"/>
-    <p:sldId xmlns:r="http://schemas.openxmlformats.org/officeDocument/2006/relationships" id="261" r:id="Re4e914a2f15a4b30"/>
-    <p:sldId xmlns:r="http://schemas.openxmlformats.org/officeDocument/2006/relationships" id="262" r:id="Rade83ff1498445b9"/>
-    <p:sldId xmlns:r="http://schemas.openxmlformats.org/officeDocument/2006/relationships" id="263" r:id="R9d161b44fb4945b1"/>
+    <p:sldId xmlns:r="http://schemas.openxmlformats.org/officeDocument/2006/relationships" id="256" r:id="R1ed6f22ddc534aef"/>
+    <p:sldId xmlns:r="http://schemas.openxmlformats.org/officeDocument/2006/relationships" id="257" r:id="R778fe5c43b7a4caa"/>
+    <p:sldId xmlns:r="http://schemas.openxmlformats.org/officeDocument/2006/relationships" id="258" r:id="R9efe814d21614e12"/>
+    <p:sldId xmlns:r="http://schemas.openxmlformats.org/officeDocument/2006/relationships" id="259" r:id="R28da96e241164f9e"/>
+    <p:sldId xmlns:r="http://schemas.openxmlformats.org/officeDocument/2006/relationships" id="260" r:id="R50bcfd7830224d0f"/>
+    <p:sldId xmlns:r="http://schemas.openxmlformats.org/officeDocument/2006/relationships" id="261" r:id="Rf761403a5cd444b9"/>
+    <p:sldId xmlns:r="http://schemas.openxmlformats.org/officeDocument/2006/relationships" id="262" r:id="R8dd6b4531b604982"/>
+    <p:sldId xmlns:r="http://schemas.openxmlformats.org/officeDocument/2006/relationships" id="263" r:id="R9d50569585b04c28"/>
   </p:sldIdLst>
   <p:sldSz cx="12192000" cy="6858000"/>
   <p:notesSz cx="6858000" cy="9144000"/>
@@ -469,7 +469,7 @@
           </a:p>
           <a:p xmlns:a="http://schemas.openxmlformats.org/drawingml/2006/main">
             <a:r>
-              <a:t>We are Owen Zhang and Joonseo Moon. We are designing an autonomous agent to repair software packages that fail after migration between hardware architectures. Our team is Anthony Capraru, Austin Li, Joonseo Moon, Juliette Jacques, and Owen Zhang, with mentor Minghua Ma at Microsoft. Today we will explain the problem, the proposed repair loop, how success is independently checked, and the milestones we intend to commit to. This is a design proposal. We have verified the supplied starter example on Linux, while our general LLM agent remains to be implemented.</a:t>
+              <a:t>We are Owen Zhang and Joonseo Moon. We are designing an autonomous agent to repair software packages that fail after migration between hardware architectures. Our team is Anthony Capraru, Austin Li, Joonseo Moon, Juliette Jacques, and Owen Zhang, with mentor Minghua Ma at Microsoft. Today we will explain the problem, the proposed repair loop, how success is independently checked, and our semester milestones. This is a design proposal. We have verified the supplied starter example on Linux, while our general LLM agent remains to be implemented.</a:t>
             </a:r>
           </a:p>
           <a:p xmlns:a="http://schemas.openxmlformats.org/drawingml/2006/main">
@@ -1069,7 +1069,7 @@
           </a:p>
           <a:p xmlns:a="http://schemas.openxmlformats.org/drawingml/2006/main">
             <a:r>
-              <a:t>For Demo 2, the prototype must invoke a model, inspect files, produce an allowed edit and completion record, and reach clean validation. We propose ten fixed public cases with five in each available direction and a reproducible baseline. Demo 2 does not promise a particular success rate. For Demo 3, categorize failures and implement one substantive improvement. The target is one additional repair per ten cases on average, with positive net gains in at least two of three full runs. The alternative is twenty percent fewer aggregate model tokens while retaining every previously repaired case in the corresponding runs, with at least one verified repair overall. Keep the same model and budget ceilings and report all attempts. A configuration flag isolates the improvement for an ablation. The final target is forty cases balanced by direction, including thirty package-grouped held-out cases frozen before optimization. Preserve complete results and reproducibility instructions. These counts and caps are proposed team commitments to review before submission. The website lists a November thirteenth competition freeze, before Demo 3. If we enter, qualification and a frozen version must be ready earlier; December is only the course final reporting date.</a:t>
+              <a:t>For Demo 2, the prototype must invoke a model, inspect files, produce an allowed edit and completion record, and reach clean validation. We will evaluate ten fixed public cases, targeting five in each available direction, and establish a reproducible baseline. Demo 2 does not promise a particular success rate. For Demo 3, categorize failures and implement one substantive improvement. The target is one additional repair per ten cases on average, with positive net gains in at least two of three full runs. The alternative is twenty percent fewer aggregate model tokens while retaining every previously repaired case in the corresponding runs, with at least one verified repair overall. Keep the same model and budget ceilings and report all attempts. A configuration flag isolates the improvement for an ablation. The final target is forty cases balanced by direction, including thirty package-grouped held-out cases frozen before optimization. Preserve complete results and reproducibility instructions. These evaluation targets define our semester milestones. Resource caps will be calibrated before comparisons. The website lists a November thirteenth competition freeze, before Demo 3. If we enter, qualification and a frozen version must be ready earlier; December is only the course final reporting date.</a:t>
             </a:r>
           </a:p>
           <a:p xmlns:a="http://schemas.openxmlformats.org/drawingml/2006/main">
@@ -1247,7 +1247,7 @@
   </p:cSld>
   <p:clrMap bg1="lt1" tx1="dk1" bg2="lt2" tx2="dk2" accent1="accent1" accent2="accent2" accent3="accent3" accent4="accent4" accent5="accent5" accent6="accent6" hlink="hlink" folHlink="folHlink"/>
   <p:sldLayoutIdLst>
-    <p:sldLayoutId xmlns:r="http://schemas.openxmlformats.org/officeDocument/2006/relationships" id="2147483649" r:id="Rdef41fb5cda24715"/>
+    <p:sldLayoutId xmlns:r="http://schemas.openxmlformats.org/officeDocument/2006/relationships" id="2147483649" r:id="Rd00a3db301094390"/>
   </p:sldLayoutIdLst>
   <p:txStyles>
     <p:titleStyle>
@@ -2856,7 +2856,7 @@
       </p:sp>
       <p:cxnSp>
         <p:nvCxnSpPr>
-          <p:cNvPr id="49" name=""/>
+          <p:cNvPr id="60" name=""/>
           <p:cNvCxnSpPr>
             <a:stCxn xmlns:a="http://schemas.openxmlformats.org/drawingml/2006/main" id="5" idx="3"/>
             <a:endCxn xmlns:a="http://schemas.openxmlformats.org/drawingml/2006/main" id="8" idx="1"/>
@@ -4356,7 +4356,7 @@
       </p:sp>
       <p:cxnSp>
         <p:nvCxnSpPr>
-          <p:cNvPr id="105" name=""/>
+          <p:cNvPr id="132" name=""/>
           <p:cNvCxnSpPr>
             <a:stCxn xmlns:a="http://schemas.openxmlformats.org/drawingml/2006/main" id="5" idx="3"/>
             <a:endCxn xmlns:a="http://schemas.openxmlformats.org/drawingml/2006/main" id="8" idx="1"/>
@@ -4381,7 +4381,7 @@
       </p:cxnSp>
       <p:cxnSp>
         <p:nvCxnSpPr>
-          <p:cNvPr id="106" name=""/>
+          <p:cNvPr id="133" name=""/>
           <p:cNvCxnSpPr>
             <a:stCxn xmlns:a="http://schemas.openxmlformats.org/drawingml/2006/main" id="8" idx="3"/>
             <a:endCxn xmlns:a="http://schemas.openxmlformats.org/drawingml/2006/main" id="11" idx="1"/>
@@ -4406,7 +4406,7 @@
       </p:cxnSp>
       <p:cxnSp>
         <p:nvCxnSpPr>
-          <p:cNvPr id="107" name=""/>
+          <p:cNvPr id="134" name=""/>
           <p:cNvCxnSpPr>
             <a:stCxn xmlns:a="http://schemas.openxmlformats.org/drawingml/2006/main" id="11" idx="2"/>
             <a:endCxn xmlns:a="http://schemas.openxmlformats.org/drawingml/2006/main" id="14" idx="0"/>
@@ -4431,7 +4431,7 @@
       </p:cxnSp>
       <p:cxnSp>
         <p:nvCxnSpPr>
-          <p:cNvPr id="108" name=""/>
+          <p:cNvPr id="135" name=""/>
           <p:cNvCxnSpPr>
             <a:stCxn xmlns:a="http://schemas.openxmlformats.org/drawingml/2006/main" id="17" idx="3"/>
             <a:endCxn xmlns:a="http://schemas.openxmlformats.org/drawingml/2006/main" id="14" idx="1"/>
@@ -4456,7 +4456,7 @@
       </p:cxnSp>
       <p:cxnSp>
         <p:nvCxnSpPr>
-          <p:cNvPr id="109" name=""/>
+          <p:cNvPr id="136" name=""/>
           <p:cNvCxnSpPr>
             <a:stCxn xmlns:a="http://schemas.openxmlformats.org/drawingml/2006/main" id="20" idx="3"/>
             <a:endCxn xmlns:a="http://schemas.openxmlformats.org/drawingml/2006/main" id="17" idx="1"/>
@@ -5846,7 +5846,7 @@
       </p:sp>
       <p:cxnSp>
         <p:nvCxnSpPr>
-          <p:cNvPr id="126" name=""/>
+          <p:cNvPr id="158" name=""/>
           <p:cNvCxnSpPr>
             <a:stCxn xmlns:a="http://schemas.openxmlformats.org/drawingml/2006/main" id="5" idx="3"/>
             <a:endCxn xmlns:a="http://schemas.openxmlformats.org/drawingml/2006/main" id="8" idx="1"/>
@@ -5871,7 +5871,7 @@
       </p:cxnSp>
       <p:cxnSp>
         <p:nvCxnSpPr>
-          <p:cNvPr id="127" name=""/>
+          <p:cNvPr id="159" name=""/>
           <p:cNvCxnSpPr>
             <a:stCxn xmlns:a="http://schemas.openxmlformats.org/drawingml/2006/main" id="8" idx="3"/>
             <a:endCxn xmlns:a="http://schemas.openxmlformats.org/drawingml/2006/main" id="11" idx="1"/>
@@ -5896,7 +5896,7 @@
       </p:cxnSp>
       <p:cxnSp>
         <p:nvCxnSpPr>
-          <p:cNvPr id="128" name=""/>
+          <p:cNvPr id="160" name=""/>
           <p:cNvCxnSpPr>
             <a:stCxn xmlns:a="http://schemas.openxmlformats.org/drawingml/2006/main" id="11" idx="3"/>
             <a:endCxn xmlns:a="http://schemas.openxmlformats.org/drawingml/2006/main" id="14" idx="1"/>
@@ -5921,7 +5921,7 @@
       </p:cxnSp>
       <p:cxnSp>
         <p:nvCxnSpPr>
-          <p:cNvPr id="129" name=""/>
+          <p:cNvPr id="161" name=""/>
           <p:cNvCxnSpPr>
             <a:stCxn xmlns:a="http://schemas.openxmlformats.org/drawingml/2006/main" id="14" idx="2"/>
             <a:endCxn xmlns:a="http://schemas.openxmlformats.org/drawingml/2006/main" id="17" idx="0"/>
@@ -5946,7 +5946,7 @@
       </p:cxnSp>
       <p:cxnSp>
         <p:nvCxnSpPr>
-          <p:cNvPr id="130" name=""/>
+          <p:cNvPr id="162" name=""/>
           <p:cNvCxnSpPr>
             <a:stCxn xmlns:a="http://schemas.openxmlformats.org/drawingml/2006/main" id="20" idx="3"/>
             <a:endCxn xmlns:a="http://schemas.openxmlformats.org/drawingml/2006/main" id="17" idx="1"/>
@@ -5971,7 +5971,7 @@
       </p:cxnSp>
       <p:cxnSp>
         <p:nvCxnSpPr>
-          <p:cNvPr id="131" name=""/>
+          <p:cNvPr id="163" name=""/>
           <p:cNvCxnSpPr>
             <a:stCxn xmlns:a="http://schemas.openxmlformats.org/drawingml/2006/main" id="23" idx="3"/>
             <a:endCxn xmlns:a="http://schemas.openxmlformats.org/drawingml/2006/main" id="20" idx="1"/>
@@ -5996,7 +5996,7 @@
       </p:cxnSp>
       <p:cxnSp>
         <p:nvCxnSpPr>
-          <p:cNvPr id="132" name=""/>
+          <p:cNvPr id="164" name=""/>
           <p:cNvCxnSpPr>
             <a:stCxn xmlns:a="http://schemas.openxmlformats.org/drawingml/2006/main" id="8" idx="2"/>
             <a:endCxn xmlns:a="http://schemas.openxmlformats.org/drawingml/2006/main" id="20" idx="0"/>
@@ -9466,7 +9466,7 @@
                 <a:ea typeface="Helvetica Neue"/>
                 <a:cs typeface="Helvetica Neue"/>
               </a:rPr>
-              <a:t>Proposed targets. Repeat all 10 cases, hold budgets fixed and report every regression.</a:t>
+              <a:t>Evaluation targets. Repeat all 10 cases, hold budgets fixed and report every regression.</a:t>
             </a:r>
           </a:p>
         </p:txBody>

</xml_diff>

<commit_message>
Mention smoke test less
</commit_message>
<xml_diff>
--- a/slides/demo-1.pptx
+++ b/slides/demo-1.pptx
@@ -2,20 +2,20 @@
 <file path=ppt/presentation.xml><?xml version="1.0" encoding="utf-8"?>
 <p:presentation xmlns:p="http://schemas.openxmlformats.org/presentationml/2006/main">
   <p:sldMasterIdLst>
-    <p:sldMasterId xmlns:r="http://schemas.openxmlformats.org/officeDocument/2006/relationships" id="2147483648" r:id="Re0c68cff40774ddb"/>
+    <p:sldMasterId xmlns:r="http://schemas.openxmlformats.org/officeDocument/2006/relationships" id="2147483648" r:id="R6326f3ec5a1b45ea"/>
   </p:sldMasterIdLst>
   <p:notesMasterIdLst>
-    <p:notesMasterId xmlns:r="http://schemas.openxmlformats.org/officeDocument/2006/relationships" r:id="Rce8af401aa51415c"/>
+    <p:notesMasterId xmlns:r="http://schemas.openxmlformats.org/officeDocument/2006/relationships" r:id="R50d062b34bfd453c"/>
   </p:notesMasterIdLst>
   <p:sldIdLst>
-    <p:sldId xmlns:r="http://schemas.openxmlformats.org/officeDocument/2006/relationships" id="256" r:id="R1ed6f22ddc534aef"/>
-    <p:sldId xmlns:r="http://schemas.openxmlformats.org/officeDocument/2006/relationships" id="257" r:id="R778fe5c43b7a4caa"/>
-    <p:sldId xmlns:r="http://schemas.openxmlformats.org/officeDocument/2006/relationships" id="258" r:id="R9efe814d21614e12"/>
-    <p:sldId xmlns:r="http://schemas.openxmlformats.org/officeDocument/2006/relationships" id="259" r:id="R28da96e241164f9e"/>
-    <p:sldId xmlns:r="http://schemas.openxmlformats.org/officeDocument/2006/relationships" id="260" r:id="R50bcfd7830224d0f"/>
-    <p:sldId xmlns:r="http://schemas.openxmlformats.org/officeDocument/2006/relationships" id="261" r:id="Rf761403a5cd444b9"/>
-    <p:sldId xmlns:r="http://schemas.openxmlformats.org/officeDocument/2006/relationships" id="262" r:id="R8dd6b4531b604982"/>
-    <p:sldId xmlns:r="http://schemas.openxmlformats.org/officeDocument/2006/relationships" id="263" r:id="R9d50569585b04c28"/>
+    <p:sldId xmlns:r="http://schemas.openxmlformats.org/officeDocument/2006/relationships" id="256" r:id="R7a86b0b378654334"/>
+    <p:sldId xmlns:r="http://schemas.openxmlformats.org/officeDocument/2006/relationships" id="257" r:id="R24ab2def967343f4"/>
+    <p:sldId xmlns:r="http://schemas.openxmlformats.org/officeDocument/2006/relationships" id="258" r:id="Rb648ba6e4f5749fe"/>
+    <p:sldId xmlns:r="http://schemas.openxmlformats.org/officeDocument/2006/relationships" id="259" r:id="R2b8a49ea45e34271"/>
+    <p:sldId xmlns:r="http://schemas.openxmlformats.org/officeDocument/2006/relationships" id="260" r:id="R92de3a8ac8654057"/>
+    <p:sldId xmlns:r="http://schemas.openxmlformats.org/officeDocument/2006/relationships" id="261" r:id="R04df7f5a68d44bd7"/>
+    <p:sldId xmlns:r="http://schemas.openxmlformats.org/officeDocument/2006/relationships" id="262" r:id="R5a8075affe5243ff"/>
+    <p:sldId xmlns:r="http://schemas.openxmlformats.org/officeDocument/2006/relationships" id="263" r:id="Raa665de2dace4596"/>
   </p:sldIdLst>
   <p:sldSz cx="12192000" cy="6858000"/>
   <p:notesSz cx="6858000" cy="9144000"/>
@@ -469,7 +469,7 @@
           </a:p>
           <a:p xmlns:a="http://schemas.openxmlformats.org/drawingml/2006/main">
             <a:r>
-              <a:t>We are Owen Zhang and Joonseo Moon. We are designing an autonomous agent to repair software packages that fail after migration between hardware architectures. Our team is Anthony Capraru, Austin Li, Joonseo Moon, Juliette Jacques, and Owen Zhang, with mentor Minghua Ma at Microsoft. Today we will explain the problem, the proposed repair loop, how success is independently checked, and our semester milestones. This is a design proposal. We have verified the supplied starter example on Linux, while our general LLM agent remains to be implemented.</a:t>
+              <a:t>We are Owen Zhang and Joonseo Moon. We are designing an autonomous agent to repair software packages that fail after migration between hardware architectures. Our team is Anthony Capraru, Austin Li, Joonseo Moon, Juliette Jacques, and Owen Zhang, with mentor Minghua Ma at Microsoft. Today we will explain the problem, the proposed repair loop, how success is independently checked, and our semester milestones. This is a design proposal; our general LLM agent is scheduled for Demo 2.</a:t>
             </a:r>
           </a:p>
           <a:p xmlns:a="http://schemas.openxmlformats.org/drawingml/2006/main">
@@ -669,7 +669,7 @@
           </a:p>
           <a:p xmlns:a="http://schemas.openxmlformats.org/drawingml/2006/main">
             <a:r>
-              <a:t>Read the diagram from the upper left across the top row, then down and back across the bottom. Cases describe a package that worked on a source architecture and failed on a target architecture. We have the target-failure evidence; we have not independently reproduced source success for the development dataset. The agent edits its permitted working repository. The organizer then derives a canonical patch, applies it to a fresh case, and runs the target build with expected artifact verification. Completion status and a plausible patch are insufficient. The downloaded public release contains 100 cases in each x86_64/ARM64 direction. The broader competition includes RISC-V, but RISC-V is outside our available public-case evidence. The supplied hello example is a separate RPM smoke case, not one of those 200 Debian cases.</a:t>
+              <a:t>Read the diagram from the upper left across the top row, then down and back across the bottom. Cases describe a package that worked on a source architecture and failed on a target architecture. We have the target-failure evidence; we have not independently reproduced source success for the development dataset. The agent edits its permitted working repository. The organizer then derives a canonical patch, applies it to a fresh case, and runs the target build with expected artifact verification. Completion status and a plausible patch are insufficient. The downloaded public release contains 100 cases in each x86_64/ARM64 direction. The broader competition includes RISC-V, but RISC-V is outside our available public-case evidence.</a:t>
             </a:r>
           </a:p>
           <a:p xmlns:a="http://schemas.openxmlformats.org/drawingml/2006/main">
@@ -969,7 +969,7 @@
           </a:p>
           <a:p xmlns:a="http://schemas.openxmlformats.org/drawingml/2006/main">
             <a:r>
-              <a:t>The primary metric is the number of cases meeting clean-patch, target-build and artifact requirements divided by every case in a frozen set. We retain crashes, timeouts, invalid patches and unresolved cases in that denominator, and report infrastructure failures separately. Any runnable-case-only rate must be labeled with its own denominator. We will compare the organizer-linked baseline where it can be reproduced, pinning its version, model and configuration. If it is incompatible, we will document that and use an explicitly named one-shot comparator provisionally. The hello example is not this baseline. Record total wall time, tokens, attempts and tool calls. Run each compared configuration three times on all ten development cases. Report every run and regression, not only repeats on cases that improved. We will group related package names between development and held-out cases to reduce tuning leakage. No public result can establish hidden-case performance.</a:t>
+              <a:t>The primary metric is the number of cases meeting clean-patch, target-build and artifact requirements divided by every case in a frozen set. We retain crashes, timeouts, invalid patches and unresolved cases in that denominator, and report infrastructure failures separately. Any runnable-case-only rate must be labeled with its own denominator. We will compare the organizer-linked baseline where it can be reproduced, pinning its version, model and configuration. If it is incompatible, we will document that and use an explicitly named one-shot comparator provisionally. Record total wall time, tokens, attempts and tool calls. Run each compared configuration three times on all ten development cases. Report every run and regression, not only repeats on cases that improved. We will group related package names between development and held-out cases to reduce tuning leakage. No public result can establish hidden-case performance.</a:t>
             </a:r>
           </a:p>
           <a:p xmlns:a="http://schemas.openxmlformats.org/drawingml/2006/main">
@@ -1149,7 +1149,7 @@
           <a:lstStyle xmlns:a="http://schemas.openxmlformats.org/drawingml/2006/main"/>
           <a:p xmlns:a="http://schemas.openxmlformats.org/drawingml/2006/main">
             <a:r>
-              <a:t>8. Organizer’s hello workflow reproduced (55 seconds)</a:t>
+              <a:t>8. Current status and next steps (55 seconds)</a:t>
             </a:r>
           </a:p>
           <a:p xmlns:a="http://schemas.openxmlformats.org/drawingml/2006/main">
@@ -1169,7 +1169,7 @@
           </a:p>
           <a:p xmlns:a="http://schemas.openxmlformats.org/drawingml/2006/main">
             <a:r>
-              <a:t>We reproduced the organizer's hello workflow on the Linux VPS. This is not a Build-Bench repair result from our agent. The initial build failed, the example agent replaced a known marker, and the canonical patch passed a fresh build with both RPM artifacts verified. The reported nine seconds measures only the final build. No LLM or public-case repair evaluation has run. The VPS is historical smoke-test evidence. We plan to run course experiments on AWS with pinned x86_64 and ARM64 environments. AWS does not solve Debian case reconstruction, historical dependencies or the hosted model and feedback interface. Those are the immediate technical questions. Our hardest challenge is selecting useful evidence and revising diagnoses within a budget.</a:t>
+              <a:t>We have inspected the 200-case release across 188 packages and reproduced the organizer's hello example on Linux. Our LLM repair agent and public-case evaluation are scheduled for Demo 2. The first priority is a reproducible Debian case: provision the planned AWS environments, pin their configurations and reproduce the original failure. In parallel, confirm the supported model and feedback interfaces and implement the bounded repair loop. AWS provides the planned compute environment, but historical dependencies and hosted compatibility still need verification. This setup lets us evaluate the central question: can better evidence selection and repair history improve verified repairs or reduce model usage? Our hardest challenge is choosing useful evidence and revising diagnoses within a budget.</a:t>
             </a:r>
           </a:p>
           <a:p xmlns:a="http://schemas.openxmlformats.org/drawingml/2006/main">
@@ -1179,7 +1179,7 @@
           </a:p>
           <a:p xmlns:a="http://schemas.openxmlformats.org/drawingml/2006/main">
             <a:r>
-              <a:t>Sources: docs/evidence/demo-1/{initial-build-result.json,agent-result.json,build-result.json,repair.diff,SHA256SUMS}. Run finished 2026-09-21 23:27:24 UTC.</a:t>
+              <a:t>Sources: docs/evidence/demo-1/dataset-summary.json and docs/evidence/demo-1/README.md. Development priorities: docs/design-proposal.md.</a:t>
             </a:r>
           </a:p>
         </p:txBody>
@@ -1247,7 +1247,7 @@
   </p:cSld>
   <p:clrMap bg1="lt1" tx1="dk1" bg2="lt2" tx2="dk2" accent1="accent1" accent2="accent2" accent3="accent3" accent4="accent4" accent5="accent5" accent6="accent6" hlink="hlink" folHlink="folHlink"/>
   <p:sldLayoutIdLst>
-    <p:sldLayoutId xmlns:r="http://schemas.openxmlformats.org/officeDocument/2006/relationships" id="2147483649" r:id="Rd00a3db301094390"/>
+    <p:sldLayoutId xmlns:r="http://schemas.openxmlformats.org/officeDocument/2006/relationships" id="2147483649" r:id="Rc8de08fd734c4616"/>
   </p:sldLayoutIdLst>
   <p:txStyles>
     <p:titleStyle>
@@ -2856,7 +2856,7 @@
       </p:sp>
       <p:cxnSp>
         <p:nvCxnSpPr>
-          <p:cNvPr id="60" name=""/>
+          <p:cNvPr id="71" name=""/>
           <p:cNvCxnSpPr>
             <a:stCxn xmlns:a="http://schemas.openxmlformats.org/drawingml/2006/main" id="5" idx="3"/>
             <a:endCxn xmlns:a="http://schemas.openxmlformats.org/drawingml/2006/main" id="8" idx="1"/>
@@ -4356,7 +4356,7 @@
       </p:sp>
       <p:cxnSp>
         <p:nvCxnSpPr>
-          <p:cNvPr id="132" name=""/>
+          <p:cNvPr id="159" name=""/>
           <p:cNvCxnSpPr>
             <a:stCxn xmlns:a="http://schemas.openxmlformats.org/drawingml/2006/main" id="5" idx="3"/>
             <a:endCxn xmlns:a="http://schemas.openxmlformats.org/drawingml/2006/main" id="8" idx="1"/>
@@ -4381,7 +4381,7 @@
       </p:cxnSp>
       <p:cxnSp>
         <p:nvCxnSpPr>
-          <p:cNvPr id="133" name=""/>
+          <p:cNvPr id="160" name=""/>
           <p:cNvCxnSpPr>
             <a:stCxn xmlns:a="http://schemas.openxmlformats.org/drawingml/2006/main" id="8" idx="3"/>
             <a:endCxn xmlns:a="http://schemas.openxmlformats.org/drawingml/2006/main" id="11" idx="1"/>
@@ -4406,7 +4406,7 @@
       </p:cxnSp>
       <p:cxnSp>
         <p:nvCxnSpPr>
-          <p:cNvPr id="134" name=""/>
+          <p:cNvPr id="161" name=""/>
           <p:cNvCxnSpPr>
             <a:stCxn xmlns:a="http://schemas.openxmlformats.org/drawingml/2006/main" id="11" idx="2"/>
             <a:endCxn xmlns:a="http://schemas.openxmlformats.org/drawingml/2006/main" id="14" idx="0"/>
@@ -4431,7 +4431,7 @@
       </p:cxnSp>
       <p:cxnSp>
         <p:nvCxnSpPr>
-          <p:cNvPr id="135" name=""/>
+          <p:cNvPr id="162" name=""/>
           <p:cNvCxnSpPr>
             <a:stCxn xmlns:a="http://schemas.openxmlformats.org/drawingml/2006/main" id="17" idx="3"/>
             <a:endCxn xmlns:a="http://schemas.openxmlformats.org/drawingml/2006/main" id="14" idx="1"/>
@@ -4456,7 +4456,7 @@
       </p:cxnSp>
       <p:cxnSp>
         <p:nvCxnSpPr>
-          <p:cNvPr id="136" name=""/>
+          <p:cNvPr id="163" name=""/>
           <p:cNvCxnSpPr>
             <a:stCxn xmlns:a="http://schemas.openxmlformats.org/drawingml/2006/main" id="20" idx="3"/>
             <a:endCxn xmlns:a="http://schemas.openxmlformats.org/drawingml/2006/main" id="17" idx="1"/>
@@ -5846,7 +5846,7 @@
       </p:sp>
       <p:cxnSp>
         <p:nvCxnSpPr>
-          <p:cNvPr id="158" name=""/>
+          <p:cNvPr id="190" name=""/>
           <p:cNvCxnSpPr>
             <a:stCxn xmlns:a="http://schemas.openxmlformats.org/drawingml/2006/main" id="5" idx="3"/>
             <a:endCxn xmlns:a="http://schemas.openxmlformats.org/drawingml/2006/main" id="8" idx="1"/>
@@ -5871,7 +5871,7 @@
       </p:cxnSp>
       <p:cxnSp>
         <p:nvCxnSpPr>
-          <p:cNvPr id="159" name=""/>
+          <p:cNvPr id="191" name=""/>
           <p:cNvCxnSpPr>
             <a:stCxn xmlns:a="http://schemas.openxmlformats.org/drawingml/2006/main" id="8" idx="3"/>
             <a:endCxn xmlns:a="http://schemas.openxmlformats.org/drawingml/2006/main" id="11" idx="1"/>
@@ -5896,7 +5896,7 @@
       </p:cxnSp>
       <p:cxnSp>
         <p:nvCxnSpPr>
-          <p:cNvPr id="160" name=""/>
+          <p:cNvPr id="192" name=""/>
           <p:cNvCxnSpPr>
             <a:stCxn xmlns:a="http://schemas.openxmlformats.org/drawingml/2006/main" id="11" idx="3"/>
             <a:endCxn xmlns:a="http://schemas.openxmlformats.org/drawingml/2006/main" id="14" idx="1"/>
@@ -5921,7 +5921,7 @@
       </p:cxnSp>
       <p:cxnSp>
         <p:nvCxnSpPr>
-          <p:cNvPr id="161" name=""/>
+          <p:cNvPr id="193" name=""/>
           <p:cNvCxnSpPr>
             <a:stCxn xmlns:a="http://schemas.openxmlformats.org/drawingml/2006/main" id="14" idx="2"/>
             <a:endCxn xmlns:a="http://schemas.openxmlformats.org/drawingml/2006/main" id="17" idx="0"/>
@@ -5946,7 +5946,7 @@
       </p:cxnSp>
       <p:cxnSp>
         <p:nvCxnSpPr>
-          <p:cNvPr id="162" name=""/>
+          <p:cNvPr id="194" name=""/>
           <p:cNvCxnSpPr>
             <a:stCxn xmlns:a="http://schemas.openxmlformats.org/drawingml/2006/main" id="20" idx="3"/>
             <a:endCxn xmlns:a="http://schemas.openxmlformats.org/drawingml/2006/main" id="17" idx="1"/>
@@ -5971,7 +5971,7 @@
       </p:cxnSp>
       <p:cxnSp>
         <p:nvCxnSpPr>
-          <p:cNvPr id="163" name=""/>
+          <p:cNvPr id="195" name=""/>
           <p:cNvCxnSpPr>
             <a:stCxn xmlns:a="http://schemas.openxmlformats.org/drawingml/2006/main" id="23" idx="3"/>
             <a:endCxn xmlns:a="http://schemas.openxmlformats.org/drawingml/2006/main" id="20" idx="1"/>
@@ -5996,7 +5996,7 @@
       </p:cxnSp>
       <p:cxnSp>
         <p:nvCxnSpPr>
-          <p:cNvPr id="164" name=""/>
+          <p:cNvPr id="196" name=""/>
           <p:cNvCxnSpPr>
             <a:stCxn xmlns:a="http://schemas.openxmlformats.org/drawingml/2006/main" id="8" idx="2"/>
             <a:endCxn xmlns:a="http://schemas.openxmlformats.org/drawingml/2006/main" id="20" idx="0"/>
@@ -9553,7 +9553,7 @@
                 <a:ea typeface="Helvetica Neue"/>
                 <a:cs typeface="Helvetica Neue"/>
               </a:rPr>
-              <a:t>Organizer’s hello workflow reproduced</a:t>
+              <a:t>Current status and next steps</a:t>
             </a:r>
           </a:p>
         </p:txBody>
@@ -9690,44 +9690,44 @@
         </p:nvSpPr>
         <p:spPr>
           <a:xfrm xmlns:a="http://schemas.openxmlformats.org/drawingml/2006/main">
-            <a:off x="609600" y="1609725"/>
-            <a:ext cx="5048250" cy="333375"/>
-          </a:xfrm>
-          <a:prstGeom xmlns:a="http://schemas.openxmlformats.org/drawingml/2006/main" prst="rect">
-            <a:avLst/>
-          </a:prstGeom>
-          <a:noFill xmlns:a="http://schemas.openxmlformats.org/drawingml/2006/main"/>
-          <a:ln xmlns:a="http://schemas.openxmlformats.org/drawingml/2006/main" w="0">
-            <a:noFill/>
-          </a:ln>
-        </p:spPr>
-        <p:txBody>
-          <a:bodyPr xmlns:a="http://schemas.openxmlformats.org/drawingml/2006/main" lIns="0" tIns="0" rIns="0" bIns="0" anchor="t">
-            <a:noAutofit/>
-          </a:bodyPr>
-          <a:lstStyle xmlns:a="http://schemas.openxmlformats.org/drawingml/2006/main"/>
-          <a:p xmlns:a="http://schemas.openxmlformats.org/drawingml/2006/main">
-            <a:pPr algn="l">
-              <a:buNone/>
-              <a:defRPr sz="1725" b="1">
-                <a:solidFill>
-                  <a:srgbClr val="19715B"/>
-                </a:solidFill>
-                <a:latin typeface="Helvetica Neue"/>
-                <a:ea typeface="Helvetica Neue"/>
-                <a:cs typeface="Helvetica Neue"/>
-              </a:defRPr>
-            </a:pPr>
-            <a:r>
-              <a:rPr sz="1725" b="1">
-                <a:solidFill>
-                  <a:srgbClr val="19715B"/>
-                </a:solidFill>
-                <a:latin typeface="Helvetica Neue"/>
-                <a:ea typeface="Helvetica Neue"/>
-                <a:cs typeface="Helvetica Neue"/>
-              </a:rPr>
-              <a:t>ORGANIZER EXAMPLE, NO LLM</a:t>
+            <a:off x="609600" y="1543050"/>
+            <a:ext cx="10972800" cy="333375"/>
+          </a:xfrm>
+          <a:prstGeom xmlns:a="http://schemas.openxmlformats.org/drawingml/2006/main" prst="rect">
+            <a:avLst/>
+          </a:prstGeom>
+          <a:noFill xmlns:a="http://schemas.openxmlformats.org/drawingml/2006/main"/>
+          <a:ln xmlns:a="http://schemas.openxmlformats.org/drawingml/2006/main" w="0">
+            <a:noFill/>
+          </a:ln>
+        </p:spPr>
+        <p:txBody>
+          <a:bodyPr xmlns:a="http://schemas.openxmlformats.org/drawingml/2006/main" lIns="0" tIns="0" rIns="0" bIns="0" anchor="t">
+            <a:noAutofit/>
+          </a:bodyPr>
+          <a:lstStyle xmlns:a="http://schemas.openxmlformats.org/drawingml/2006/main"/>
+          <a:p xmlns:a="http://schemas.openxmlformats.org/drawingml/2006/main">
+            <a:pPr algn="l">
+              <a:buNone/>
+              <a:defRPr sz="1950" b="1">
+                <a:solidFill>
+                  <a:srgbClr val="17765F"/>
+                </a:solidFill>
+                <a:latin typeface="Helvetica Neue"/>
+                <a:ea typeface="Helvetica Neue"/>
+                <a:cs typeface="Helvetica Neue"/>
+              </a:defRPr>
+            </a:pPr>
+            <a:r>
+              <a:rPr sz="1950" b="1">
+                <a:solidFill>
+                  <a:srgbClr val="17765F"/>
+                </a:solidFill>
+                <a:latin typeface="Helvetica Neue"/>
+                <a:ea typeface="Helvetica Neue"/>
+                <a:cs typeface="Helvetica Neue"/>
+              </a:rPr>
+              <a:t>CURRENT STATUS</a:t>
             </a:r>
           </a:p>
         </p:txBody>
@@ -9748,44 +9748,44 @@
         </p:nvSpPr>
         <p:spPr>
           <a:xfrm xmlns:a="http://schemas.openxmlformats.org/drawingml/2006/main">
-            <a:off x="609600" y="2133600"/>
-            <a:ext cx="10668000" cy="476250"/>
-          </a:xfrm>
-          <a:prstGeom xmlns:a="http://schemas.openxmlformats.org/drawingml/2006/main" prst="rect">
-            <a:avLst/>
-          </a:prstGeom>
-          <a:noFill xmlns:a="http://schemas.openxmlformats.org/drawingml/2006/main"/>
-          <a:ln xmlns:a="http://schemas.openxmlformats.org/drawingml/2006/main" w="0">
-            <a:noFill/>
-          </a:ln>
-        </p:spPr>
-        <p:txBody>
-          <a:bodyPr xmlns:a="http://schemas.openxmlformats.org/drawingml/2006/main" lIns="0" tIns="0" rIns="0" bIns="0" anchor="t">
-            <a:noAutofit/>
-          </a:bodyPr>
-          <a:lstStyle xmlns:a="http://schemas.openxmlformats.org/drawingml/2006/main"/>
-          <a:p xmlns:a="http://schemas.openxmlformats.org/drawingml/2006/main">
-            <a:pPr algn="l">
-              <a:buNone/>
-              <a:defRPr sz="2700" b="1">
-                <a:solidFill>
-                  <a:srgbClr val="122234"/>
-                </a:solidFill>
-                <a:latin typeface="Helvetica Neue"/>
-                <a:ea typeface="Helvetica Neue"/>
-                <a:cs typeface="Helvetica Neue"/>
-              </a:defRPr>
-            </a:pPr>
-            <a:r>
-              <a:rPr sz="2700" b="1">
-                <a:solidFill>
-                  <a:srgbClr val="122234"/>
-                </a:solidFill>
-                <a:latin typeface="Helvetica Neue"/>
-                <a:ea typeface="Helvetica Neue"/>
-                <a:cs typeface="Helvetica Neue"/>
-              </a:rPr>
-              <a:t>Initial failure → patch → clean success</a:t>
+            <a:off x="609600" y="2009775"/>
+            <a:ext cx="10972800" cy="419100"/>
+          </a:xfrm>
+          <a:prstGeom xmlns:a="http://schemas.openxmlformats.org/drawingml/2006/main" prst="rect">
+            <a:avLst/>
+          </a:prstGeom>
+          <a:noFill xmlns:a="http://schemas.openxmlformats.org/drawingml/2006/main"/>
+          <a:ln xmlns:a="http://schemas.openxmlformats.org/drawingml/2006/main" w="0">
+            <a:noFill/>
+          </a:ln>
+        </p:spPr>
+        <p:txBody>
+          <a:bodyPr xmlns:a="http://schemas.openxmlformats.org/drawingml/2006/main" lIns="0" tIns="0" rIns="0" bIns="0" anchor="t">
+            <a:noAutofit/>
+          </a:bodyPr>
+          <a:lstStyle xmlns:a="http://schemas.openxmlformats.org/drawingml/2006/main"/>
+          <a:p xmlns:a="http://schemas.openxmlformats.org/drawingml/2006/main">
+            <a:pPr algn="l">
+              <a:buNone/>
+              <a:defRPr sz="2175" b="0">
+                <a:solidFill>
+                  <a:srgbClr val="122234"/>
+                </a:solidFill>
+                <a:latin typeface="Helvetica Neue"/>
+                <a:ea typeface="Helvetica Neue"/>
+                <a:cs typeface="Helvetica Neue"/>
+              </a:defRPr>
+            </a:pPr>
+            <a:r>
+              <a:rPr sz="2175" b="0">
+                <a:solidFill>
+                  <a:srgbClr val="122234"/>
+                </a:solidFill>
+                <a:latin typeface="Helvetica Neue"/>
+                <a:ea typeface="Helvetica Neue"/>
+                <a:cs typeface="Helvetica Neue"/>
+              </a:rPr>
+              <a:t>Dataset inspected: 200 cases across 188 packages.</a:t>
             </a:r>
           </a:p>
         </p:txBody>
@@ -9806,44 +9806,44 @@
         </p:nvSpPr>
         <p:spPr>
           <a:xfrm xmlns:a="http://schemas.openxmlformats.org/drawingml/2006/main">
-            <a:off x="609600" y="2924175"/>
-            <a:ext cx="5429250" cy="561975"/>
-          </a:xfrm>
-          <a:prstGeom xmlns:a="http://schemas.openxmlformats.org/drawingml/2006/main" prst="rect">
-            <a:avLst/>
-          </a:prstGeom>
-          <a:noFill xmlns:a="http://schemas.openxmlformats.org/drawingml/2006/main"/>
-          <a:ln xmlns:a="http://schemas.openxmlformats.org/drawingml/2006/main" w="0">
-            <a:noFill/>
-          </a:ln>
-        </p:spPr>
-        <p:txBody>
-          <a:bodyPr xmlns:a="http://schemas.openxmlformats.org/drawingml/2006/main" lIns="0" tIns="0" rIns="0" bIns="0" anchor="t">
-            <a:noAutofit/>
-          </a:bodyPr>
-          <a:lstStyle xmlns:a="http://schemas.openxmlformats.org/drawingml/2006/main"/>
-          <a:p xmlns:a="http://schemas.openxmlformats.org/drawingml/2006/main">
-            <a:pPr algn="l">
-              <a:buNone/>
-              <a:defRPr sz="3075" b="1">
-                <a:solidFill>
-                  <a:srgbClr val="19715B"/>
-                </a:solidFill>
-                <a:latin typeface="Helvetica Neue"/>
-                <a:ea typeface="Helvetica Neue"/>
-                <a:cs typeface="Helvetica Neue"/>
-              </a:defRPr>
-            </a:pPr>
-            <a:r>
-              <a:rPr sz="3075" b="1">
-                <a:solidFill>
-                  <a:srgbClr val="19715B"/>
-                </a:solidFill>
-                <a:latin typeface="Helvetica Neue"/>
-                <a:ea typeface="Helvetica Neue"/>
-                <a:cs typeface="Helvetica Neue"/>
-              </a:rPr>
-              <a:t>2 verified RPM artifacts</a:t>
+            <a:off x="609600" y="2524125"/>
+            <a:ext cx="10972800" cy="400050"/>
+          </a:xfrm>
+          <a:prstGeom xmlns:a="http://schemas.openxmlformats.org/drawingml/2006/main" prst="rect">
+            <a:avLst/>
+          </a:prstGeom>
+          <a:noFill xmlns:a="http://schemas.openxmlformats.org/drawingml/2006/main"/>
+          <a:ln xmlns:a="http://schemas.openxmlformats.org/drawingml/2006/main" w="0">
+            <a:noFill/>
+          </a:ln>
+        </p:spPr>
+        <p:txBody>
+          <a:bodyPr xmlns:a="http://schemas.openxmlformats.org/drawingml/2006/main" lIns="0" tIns="0" rIns="0" bIns="0" anchor="t">
+            <a:noAutofit/>
+          </a:bodyPr>
+          <a:lstStyle xmlns:a="http://schemas.openxmlformats.org/drawingml/2006/main"/>
+          <a:p xmlns:a="http://schemas.openxmlformats.org/drawingml/2006/main">
+            <a:pPr algn="l">
+              <a:buNone/>
+              <a:defRPr sz="1950" b="0">
+                <a:solidFill>
+                  <a:srgbClr val="122234"/>
+                </a:solidFill>
+                <a:latin typeface="Helvetica Neue"/>
+                <a:ea typeface="Helvetica Neue"/>
+                <a:cs typeface="Helvetica Neue"/>
+              </a:defRPr>
+            </a:pPr>
+            <a:r>
+              <a:rPr sz="1950" b="0">
+                <a:solidFill>
+                  <a:srgbClr val="122234"/>
+                </a:solidFill>
+                <a:latin typeface="Helvetica Neue"/>
+                <a:ea typeface="Helvetica Neue"/>
+                <a:cs typeface="Helvetica Neue"/>
+              </a:rPr>
+              <a:t>Organizer’s hello example reproduced on Linux.</a:t>
             </a:r>
           </a:p>
         </p:txBody>
@@ -9864,44 +9864,44 @@
         </p:nvSpPr>
         <p:spPr>
           <a:xfrm xmlns:a="http://schemas.openxmlformats.org/drawingml/2006/main">
-            <a:off x="6800850" y="2924175"/>
-            <a:ext cx="4762500" cy="561975"/>
-          </a:xfrm>
-          <a:prstGeom xmlns:a="http://schemas.openxmlformats.org/drawingml/2006/main" prst="rect">
-            <a:avLst/>
-          </a:prstGeom>
-          <a:noFill xmlns:a="http://schemas.openxmlformats.org/drawingml/2006/main"/>
-          <a:ln xmlns:a="http://schemas.openxmlformats.org/drawingml/2006/main" w="0">
-            <a:noFill/>
-          </a:ln>
-        </p:spPr>
-        <p:txBody>
-          <a:bodyPr xmlns:a="http://schemas.openxmlformats.org/drawingml/2006/main" lIns="0" tIns="0" rIns="0" bIns="0" anchor="t">
-            <a:noAutofit/>
-          </a:bodyPr>
-          <a:lstStyle xmlns:a="http://schemas.openxmlformats.org/drawingml/2006/main"/>
-          <a:p xmlns:a="http://schemas.openxmlformats.org/drawingml/2006/main">
-            <a:pPr algn="l">
-              <a:buNone/>
-              <a:defRPr sz="3075" b="1">
-                <a:solidFill>
-                  <a:srgbClr val="19715B"/>
-                </a:solidFill>
-                <a:latin typeface="Helvetica Neue"/>
-                <a:ea typeface="Helvetica Neue"/>
-                <a:cs typeface="Helvetica Neue"/>
-              </a:defRPr>
-            </a:pPr>
-            <a:r>
-              <a:rPr sz="3075" b="1">
-                <a:solidFill>
-                  <a:srgbClr val="19715B"/>
-                </a:solidFill>
-                <a:latin typeface="Helvetica Neue"/>
-                <a:ea typeface="Helvetica Neue"/>
-                <a:cs typeface="Helvetica Neue"/>
-              </a:rPr>
-              <a:t>9 s final build</a:t>
+            <a:off x="609600" y="3000375"/>
+            <a:ext cx="10972800" cy="409575"/>
+          </a:xfrm>
+          <a:prstGeom xmlns:a="http://schemas.openxmlformats.org/drawingml/2006/main" prst="rect">
+            <a:avLst/>
+          </a:prstGeom>
+          <a:noFill xmlns:a="http://schemas.openxmlformats.org/drawingml/2006/main"/>
+          <a:ln xmlns:a="http://schemas.openxmlformats.org/drawingml/2006/main" w="0">
+            <a:noFill/>
+          </a:ln>
+        </p:spPr>
+        <p:txBody>
+          <a:bodyPr xmlns:a="http://schemas.openxmlformats.org/drawingml/2006/main" lIns="0" tIns="0" rIns="0" bIns="0" anchor="t">
+            <a:noAutofit/>
+          </a:bodyPr>
+          <a:lstStyle xmlns:a="http://schemas.openxmlformats.org/drawingml/2006/main"/>
+          <a:p xmlns:a="http://schemas.openxmlformats.org/drawingml/2006/main">
+            <a:pPr algn="l">
+              <a:buNone/>
+              <a:defRPr sz="1875" b="0">
+                <a:solidFill>
+                  <a:srgbClr val="536477"/>
+                </a:solidFill>
+                <a:latin typeface="Helvetica Neue"/>
+                <a:ea typeface="Helvetica Neue"/>
+                <a:cs typeface="Helvetica Neue"/>
+              </a:defRPr>
+            </a:pPr>
+            <a:r>
+              <a:rPr sz="1875" b="0">
+                <a:solidFill>
+                  <a:srgbClr val="536477"/>
+                </a:solidFill>
+                <a:latin typeface="Helvetica Neue"/>
+                <a:ea typeface="Helvetica Neue"/>
+                <a:cs typeface="Helvetica Neue"/>
+              </a:rPr>
+              <a:t>Our LLM repair agent and public-case evaluation are scheduled for Demo 2.</a:t>
             </a:r>
           </a:p>
         </p:txBody>
@@ -9922,8 +9922,8 @@
         </p:nvSpPr>
         <p:spPr>
           <a:xfrm xmlns:a="http://schemas.openxmlformats.org/drawingml/2006/main">
-            <a:off x="609600" y="3667125"/>
-            <a:ext cx="10972800" cy="428625"/>
+            <a:off x="609600" y="5791200"/>
+            <a:ext cx="10972800" cy="400050"/>
           </a:xfrm>
           <a:prstGeom xmlns:a="http://schemas.openxmlformats.org/drawingml/2006/main" prst="rect">
             <a:avLst/>
@@ -9943,7 +9943,7 @@
               <a:buNone/>
               <a:defRPr sz="1875" b="0">
                 <a:solidFill>
-                  <a:srgbClr val="536374"/>
+                  <a:srgbClr val="536477"/>
                 </a:solidFill>
                 <a:latin typeface="Helvetica Neue"/>
                 <a:ea typeface="Helvetica Neue"/>
@@ -9953,13 +9953,13 @@
             <a:r>
               <a:rPr sz="1875" b="0">
                 <a:solidFill>
-                  <a:srgbClr val="536374"/>
-                </a:solidFill>
-                <a:latin typeface="Helvetica Neue"/>
-                <a:ea typeface="Helvetica Neue"/>
-                <a:cs typeface="Helvetica Neue"/>
-              </a:rPr>
-              <a:t>Organizer’s example only. This is not a repair result from our agent.</a:t>
+                  <a:srgbClr val="536477"/>
+                </a:solidFill>
+                <a:latin typeface="Helvetica Neue"/>
+                <a:ea typeface="Helvetica Neue"/>
+                <a:cs typeface="Helvetica Neue"/>
+              </a:rPr>
+              <a:t>Core challenge: choose useful evidence and revise diagnoses within budget.</a:t>
             </a:r>
           </a:p>
         </p:txBody>
@@ -9980,7 +9980,7 @@
         </p:nvSpPr>
         <p:spPr>
           <a:xfrm xmlns:a="http://schemas.openxmlformats.org/drawingml/2006/main">
-            <a:off x="609600" y="4343400"/>
+            <a:off x="609600" y="3629025"/>
             <a:ext cx="10953750" cy="0"/>
           </a:xfrm>
           <a:prstGeom xmlns:a="http://schemas.openxmlformats.org/drawingml/2006/main" prst="line">
@@ -10010,44 +10010,44 @@
         </p:nvSpPr>
         <p:spPr>
           <a:xfrm xmlns:a="http://schemas.openxmlformats.org/drawingml/2006/main">
-            <a:off x="609600" y="4629150"/>
-            <a:ext cx="5048250" cy="381000"/>
-          </a:xfrm>
-          <a:prstGeom xmlns:a="http://schemas.openxmlformats.org/drawingml/2006/main" prst="rect">
-            <a:avLst/>
-          </a:prstGeom>
-          <a:noFill xmlns:a="http://schemas.openxmlformats.org/drawingml/2006/main"/>
-          <a:ln xmlns:a="http://schemas.openxmlformats.org/drawingml/2006/main" w="0">
-            <a:noFill/>
-          </a:ln>
-        </p:spPr>
-        <p:txBody>
-          <a:bodyPr xmlns:a="http://schemas.openxmlformats.org/drawingml/2006/main" lIns="0" tIns="0" rIns="0" bIns="0" anchor="t">
-            <a:noAutofit/>
-          </a:bodyPr>
-          <a:lstStyle xmlns:a="http://schemas.openxmlformats.org/drawingml/2006/main"/>
-          <a:p xmlns:a="http://schemas.openxmlformats.org/drawingml/2006/main">
-            <a:pPr algn="l">
-              <a:buNone/>
-              <a:defRPr sz="2175" b="1">
-                <a:solidFill>
-                  <a:srgbClr val="122234"/>
-                </a:solidFill>
-                <a:latin typeface="Helvetica Neue"/>
-                <a:ea typeface="Helvetica Neue"/>
-                <a:cs typeface="Helvetica Neue"/>
-              </a:defRPr>
-            </a:pPr>
-            <a:r>
-              <a:rPr sz="2175" b="1">
-                <a:solidFill>
-                  <a:srgbClr val="122234"/>
-                </a:solidFill>
-                <a:latin typeface="Helvetica Neue"/>
-                <a:ea typeface="Helvetica Neue"/>
-                <a:cs typeface="Helvetica Neue"/>
-              </a:rPr>
-              <a:t>Hardest challenge</a:t>
+            <a:off x="609600" y="3962400"/>
+            <a:ext cx="5048250" cy="409575"/>
+          </a:xfrm>
+          <a:prstGeom xmlns:a="http://schemas.openxmlformats.org/drawingml/2006/main" prst="rect">
+            <a:avLst/>
+          </a:prstGeom>
+          <a:noFill xmlns:a="http://schemas.openxmlformats.org/drawingml/2006/main"/>
+          <a:ln xmlns:a="http://schemas.openxmlformats.org/drawingml/2006/main" w="0">
+            <a:noFill/>
+          </a:ln>
+        </p:spPr>
+        <p:txBody>
+          <a:bodyPr xmlns:a="http://schemas.openxmlformats.org/drawingml/2006/main" lIns="0" tIns="0" rIns="0" bIns="0" anchor="t">
+            <a:noAutofit/>
+          </a:bodyPr>
+          <a:lstStyle xmlns:a="http://schemas.openxmlformats.org/drawingml/2006/main"/>
+          <a:p xmlns:a="http://schemas.openxmlformats.org/drawingml/2006/main">
+            <a:pPr algn="l">
+              <a:buNone/>
+              <a:defRPr sz="2250" b="1">
+                <a:solidFill>
+                  <a:srgbClr val="122234"/>
+                </a:solidFill>
+                <a:latin typeface="Helvetica Neue"/>
+                <a:ea typeface="Helvetica Neue"/>
+                <a:cs typeface="Helvetica Neue"/>
+              </a:defRPr>
+            </a:pPr>
+            <a:r>
+              <a:rPr sz="2250" b="1">
+                <a:solidFill>
+                  <a:srgbClr val="122234"/>
+                </a:solidFill>
+                <a:latin typeface="Helvetica Neue"/>
+                <a:ea typeface="Helvetica Neue"/>
+                <a:cs typeface="Helvetica Neue"/>
+              </a:rPr>
+              <a:t>Reproducible cases</a:t>
             </a:r>
           </a:p>
         </p:txBody>
@@ -10068,68 +10068,68 @@
         </p:nvSpPr>
         <p:spPr>
           <a:xfrm xmlns:a="http://schemas.openxmlformats.org/drawingml/2006/main">
-            <a:off x="609600" y="5162550"/>
-            <a:ext cx="5048250" cy="800100"/>
-          </a:xfrm>
-          <a:prstGeom xmlns:a="http://schemas.openxmlformats.org/drawingml/2006/main" prst="rect">
-            <a:avLst/>
-          </a:prstGeom>
-          <a:noFill xmlns:a="http://schemas.openxmlformats.org/drawingml/2006/main"/>
-          <a:ln xmlns:a="http://schemas.openxmlformats.org/drawingml/2006/main" w="0">
-            <a:noFill/>
-          </a:ln>
-        </p:spPr>
-        <p:txBody>
-          <a:bodyPr xmlns:a="http://schemas.openxmlformats.org/drawingml/2006/main" lIns="0" tIns="0" rIns="0" bIns="0" anchor="t">
-            <a:noAutofit/>
-          </a:bodyPr>
-          <a:lstStyle xmlns:a="http://schemas.openxmlformats.org/drawingml/2006/main"/>
-          <a:p xmlns:a="http://schemas.openxmlformats.org/drawingml/2006/main">
-            <a:pPr algn="l">
-              <a:buNone/>
-              <a:defRPr sz="2025" b="0">
-                <a:solidFill>
-                  <a:srgbClr val="122234"/>
-                </a:solidFill>
-                <a:latin typeface="Helvetica Neue"/>
-                <a:ea typeface="Helvetica Neue"/>
-                <a:cs typeface="Helvetica Neue"/>
-              </a:defRPr>
-            </a:pPr>
-            <a:r>
-              <a:rPr sz="2025" b="0">
-                <a:solidFill>
-                  <a:srgbClr val="122234"/>
-                </a:solidFill>
-                <a:latin typeface="Helvetica Neue"/>
-                <a:ea typeface="Helvetica Neue"/>
-                <a:cs typeface="Helvetica Neue"/>
-              </a:rPr>
-              <a:t>Choose useful evidence and revise</a:t>
-            </a:r>
-          </a:p>
-          <a:p xmlns:a="http://schemas.openxmlformats.org/drawingml/2006/main">
-            <a:pPr algn="l">
-              <a:buNone/>
-              <a:defRPr sz="2025" b="0">
-                <a:solidFill>
-                  <a:srgbClr val="122234"/>
-                </a:solidFill>
-                <a:latin typeface="Helvetica Neue"/>
-                <a:ea typeface="Helvetica Neue"/>
-                <a:cs typeface="Helvetica Neue"/>
-              </a:defRPr>
-            </a:pPr>
-            <a:r>
-              <a:rPr sz="2025" b="0">
-                <a:solidFill>
-                  <a:srgbClr val="122234"/>
-                </a:solidFill>
-                <a:latin typeface="Helvetica Neue"/>
-                <a:ea typeface="Helvetica Neue"/>
-                <a:cs typeface="Helvetica Neue"/>
-              </a:rPr>
-              <a:t>diagnoses within a fixed budget.</a:t>
+            <a:off x="609600" y="4524375"/>
+            <a:ext cx="5143500" cy="990600"/>
+          </a:xfrm>
+          <a:prstGeom xmlns:a="http://schemas.openxmlformats.org/drawingml/2006/main" prst="rect">
+            <a:avLst/>
+          </a:prstGeom>
+          <a:noFill xmlns:a="http://schemas.openxmlformats.org/drawingml/2006/main"/>
+          <a:ln xmlns:a="http://schemas.openxmlformats.org/drawingml/2006/main" w="0">
+            <a:noFill/>
+          </a:ln>
+        </p:spPr>
+        <p:txBody>
+          <a:bodyPr xmlns:a="http://schemas.openxmlformats.org/drawingml/2006/main" lIns="0" tIns="0" rIns="0" bIns="0" anchor="t">
+            <a:noAutofit/>
+          </a:bodyPr>
+          <a:lstStyle xmlns:a="http://schemas.openxmlformats.org/drawingml/2006/main"/>
+          <a:p xmlns:a="http://schemas.openxmlformats.org/drawingml/2006/main">
+            <a:pPr algn="l">
+              <a:buNone/>
+              <a:defRPr sz="2100" b="0">
+                <a:solidFill>
+                  <a:srgbClr val="122234"/>
+                </a:solidFill>
+                <a:latin typeface="Helvetica Neue"/>
+                <a:ea typeface="Helvetica Neue"/>
+                <a:cs typeface="Helvetica Neue"/>
+              </a:defRPr>
+            </a:pPr>
+            <a:r>
+              <a:rPr sz="2100" b="0">
+                <a:solidFill>
+                  <a:srgbClr val="122234"/>
+                </a:solidFill>
+                <a:latin typeface="Helvetica Neue"/>
+                <a:ea typeface="Helvetica Neue"/>
+                <a:cs typeface="Helvetica Neue"/>
+              </a:rPr>
+              <a:t>Provision AWS and pin configs.</a:t>
+            </a:r>
+          </a:p>
+          <a:p xmlns:a="http://schemas.openxmlformats.org/drawingml/2006/main">
+            <a:pPr algn="l">
+              <a:buNone/>
+              <a:defRPr sz="2100" b="0">
+                <a:solidFill>
+                  <a:srgbClr val="122234"/>
+                </a:solidFill>
+                <a:latin typeface="Helvetica Neue"/>
+                <a:ea typeface="Helvetica Neue"/>
+                <a:cs typeface="Helvetica Neue"/>
+              </a:defRPr>
+            </a:pPr>
+            <a:r>
+              <a:rPr sz="2100" b="0">
+                <a:solidFill>
+                  <a:srgbClr val="122234"/>
+                </a:solidFill>
+                <a:latin typeface="Helvetica Neue"/>
+                <a:ea typeface="Helvetica Neue"/>
+                <a:cs typeface="Helvetica Neue"/>
+              </a:rPr>
+              <a:t>Reproduce a Debian failure.</a:t>
             </a:r>
           </a:p>
         </p:txBody>
@@ -10150,44 +10150,44 @@
         </p:nvSpPr>
         <p:spPr>
           <a:xfrm xmlns:a="http://schemas.openxmlformats.org/drawingml/2006/main">
-            <a:off x="6419850" y="4629150"/>
-            <a:ext cx="5143500" cy="381000"/>
-          </a:xfrm>
-          <a:prstGeom xmlns:a="http://schemas.openxmlformats.org/drawingml/2006/main" prst="rect">
-            <a:avLst/>
-          </a:prstGeom>
-          <a:noFill xmlns:a="http://schemas.openxmlformats.org/drawingml/2006/main"/>
-          <a:ln xmlns:a="http://schemas.openxmlformats.org/drawingml/2006/main" w="0">
-            <a:noFill/>
-          </a:ln>
-        </p:spPr>
-        <p:txBody>
-          <a:bodyPr xmlns:a="http://schemas.openxmlformats.org/drawingml/2006/main" lIns="0" tIns="0" rIns="0" bIns="0" anchor="t">
-            <a:noAutofit/>
-          </a:bodyPr>
-          <a:lstStyle xmlns:a="http://schemas.openxmlformats.org/drawingml/2006/main"/>
-          <a:p xmlns:a="http://schemas.openxmlformats.org/drawingml/2006/main">
-            <a:pPr algn="l">
-              <a:buNone/>
-              <a:defRPr sz="2175" b="1">
-                <a:solidFill>
-                  <a:srgbClr val="122234"/>
-                </a:solidFill>
-                <a:latin typeface="Helvetica Neue"/>
-                <a:ea typeface="Helvetica Neue"/>
-                <a:cs typeface="Helvetica Neue"/>
-              </a:defRPr>
-            </a:pPr>
-            <a:r>
-              <a:rPr sz="2175" b="1">
-                <a:solidFill>
-                  <a:srgbClr val="122234"/>
-                </a:solidFill>
-                <a:latin typeface="Helvetica Neue"/>
-                <a:ea typeface="Helvetica Neue"/>
-                <a:cs typeface="Helvetica Neue"/>
-              </a:rPr>
-              <a:t>Immediate next steps</a:t>
+            <a:off x="6419850" y="3962400"/>
+            <a:ext cx="5143500" cy="409575"/>
+          </a:xfrm>
+          <a:prstGeom xmlns:a="http://schemas.openxmlformats.org/drawingml/2006/main" prst="rect">
+            <a:avLst/>
+          </a:prstGeom>
+          <a:noFill xmlns:a="http://schemas.openxmlformats.org/drawingml/2006/main"/>
+          <a:ln xmlns:a="http://schemas.openxmlformats.org/drawingml/2006/main" w="0">
+            <a:noFill/>
+          </a:ln>
+        </p:spPr>
+        <p:txBody>
+          <a:bodyPr xmlns:a="http://schemas.openxmlformats.org/drawingml/2006/main" lIns="0" tIns="0" rIns="0" bIns="0" anchor="t">
+            <a:noAutofit/>
+          </a:bodyPr>
+          <a:lstStyle xmlns:a="http://schemas.openxmlformats.org/drawingml/2006/main"/>
+          <a:p xmlns:a="http://schemas.openxmlformats.org/drawingml/2006/main">
+            <a:pPr algn="l">
+              <a:buNone/>
+              <a:defRPr sz="2250" b="1">
+                <a:solidFill>
+                  <a:srgbClr val="122234"/>
+                </a:solidFill>
+                <a:latin typeface="Helvetica Neue"/>
+                <a:ea typeface="Helvetica Neue"/>
+                <a:cs typeface="Helvetica Neue"/>
+              </a:defRPr>
+            </a:pPr>
+            <a:r>
+              <a:rPr sz="2250" b="1">
+                <a:solidFill>
+                  <a:srgbClr val="122234"/>
+                </a:solidFill>
+                <a:latin typeface="Helvetica Neue"/>
+                <a:ea typeface="Helvetica Neue"/>
+                <a:cs typeface="Helvetica Neue"/>
+              </a:rPr>
+              <a:t>Agent integration</a:t>
             </a:r>
           </a:p>
         </p:txBody>
@@ -10208,68 +10208,68 @@
         </p:nvSpPr>
         <p:spPr>
           <a:xfrm xmlns:a="http://schemas.openxmlformats.org/drawingml/2006/main">
-            <a:off x="6419850" y="5162550"/>
-            <a:ext cx="5143500" cy="800100"/>
-          </a:xfrm>
-          <a:prstGeom xmlns:a="http://schemas.openxmlformats.org/drawingml/2006/main" prst="rect">
-            <a:avLst/>
-          </a:prstGeom>
-          <a:noFill xmlns:a="http://schemas.openxmlformats.org/drawingml/2006/main"/>
-          <a:ln xmlns:a="http://schemas.openxmlformats.org/drawingml/2006/main" w="0">
-            <a:noFill/>
-          </a:ln>
-        </p:spPr>
-        <p:txBody>
-          <a:bodyPr xmlns:a="http://schemas.openxmlformats.org/drawingml/2006/main" lIns="0" tIns="0" rIns="0" bIns="0" anchor="t">
-            <a:noAutofit/>
-          </a:bodyPr>
-          <a:lstStyle xmlns:a="http://schemas.openxmlformats.org/drawingml/2006/main"/>
-          <a:p xmlns:a="http://schemas.openxmlformats.org/drawingml/2006/main">
-            <a:pPr algn="l">
-              <a:buNone/>
-              <a:defRPr sz="2025" b="0">
-                <a:solidFill>
-                  <a:srgbClr val="122234"/>
-                </a:solidFill>
-                <a:latin typeface="Helvetica Neue"/>
-                <a:ea typeface="Helvetica Neue"/>
-                <a:cs typeface="Helvetica Neue"/>
-              </a:defRPr>
-            </a:pPr>
-            <a:r>
-              <a:rPr sz="2025" b="0">
-                <a:solidFill>
-                  <a:srgbClr val="122234"/>
-                </a:solidFill>
-                <a:latin typeface="Helvetica Neue"/>
-                <a:ea typeface="Helvetica Neue"/>
-                <a:cs typeface="Helvetica Neue"/>
-              </a:rPr>
-              <a:t>Plan AWS environments and pin configs.</a:t>
-            </a:r>
-          </a:p>
-          <a:p xmlns:a="http://schemas.openxmlformats.org/drawingml/2006/main">
-            <a:pPr algn="l">
-              <a:buNone/>
-              <a:defRPr sz="2025" b="0">
-                <a:solidFill>
-                  <a:srgbClr val="122234"/>
-                </a:solidFill>
-                <a:latin typeface="Helvetica Neue"/>
-                <a:ea typeface="Helvetica Neue"/>
-                <a:cs typeface="Helvetica Neue"/>
-              </a:defRPr>
-            </a:pPr>
-            <a:r>
-              <a:rPr sz="2025" b="0">
-                <a:solidFill>
-                  <a:srgbClr val="122234"/>
-                </a:solidFill>
-                <a:latin typeface="Helvetica Neue"/>
-                <a:ea typeface="Helvetica Neue"/>
-                <a:cs typeface="Helvetica Neue"/>
-              </a:rPr>
-              <a:t>Reproduce a Debian case and confirm APIs.</a:t>
+            <a:off x="6419850" y="4524375"/>
+            <a:ext cx="5143500" cy="990600"/>
+          </a:xfrm>
+          <a:prstGeom xmlns:a="http://schemas.openxmlformats.org/drawingml/2006/main" prst="rect">
+            <a:avLst/>
+          </a:prstGeom>
+          <a:noFill xmlns:a="http://schemas.openxmlformats.org/drawingml/2006/main"/>
+          <a:ln xmlns:a="http://schemas.openxmlformats.org/drawingml/2006/main" w="0">
+            <a:noFill/>
+          </a:ln>
+        </p:spPr>
+        <p:txBody>
+          <a:bodyPr xmlns:a="http://schemas.openxmlformats.org/drawingml/2006/main" lIns="0" tIns="0" rIns="0" bIns="0" anchor="t">
+            <a:noAutofit/>
+          </a:bodyPr>
+          <a:lstStyle xmlns:a="http://schemas.openxmlformats.org/drawingml/2006/main"/>
+          <a:p xmlns:a="http://schemas.openxmlformats.org/drawingml/2006/main">
+            <a:pPr algn="l">
+              <a:buNone/>
+              <a:defRPr sz="2100" b="0">
+                <a:solidFill>
+                  <a:srgbClr val="122234"/>
+                </a:solidFill>
+                <a:latin typeface="Helvetica Neue"/>
+                <a:ea typeface="Helvetica Neue"/>
+                <a:cs typeface="Helvetica Neue"/>
+              </a:defRPr>
+            </a:pPr>
+            <a:r>
+              <a:rPr sz="2100" b="0">
+                <a:solidFill>
+                  <a:srgbClr val="122234"/>
+                </a:solidFill>
+                <a:latin typeface="Helvetica Neue"/>
+                <a:ea typeface="Helvetica Neue"/>
+                <a:cs typeface="Helvetica Neue"/>
+              </a:rPr>
+              <a:t>Confirm model and feedback APIs.</a:t>
+            </a:r>
+          </a:p>
+          <a:p xmlns:a="http://schemas.openxmlformats.org/drawingml/2006/main">
+            <a:pPr algn="l">
+              <a:buNone/>
+              <a:defRPr sz="2100" b="0">
+                <a:solidFill>
+                  <a:srgbClr val="122234"/>
+                </a:solidFill>
+                <a:latin typeface="Helvetica Neue"/>
+                <a:ea typeface="Helvetica Neue"/>
+                <a:cs typeface="Helvetica Neue"/>
+              </a:defRPr>
+            </a:pPr>
+            <a:r>
+              <a:rPr sz="2100" b="0">
+                <a:solidFill>
+                  <a:srgbClr val="122234"/>
+                </a:solidFill>
+                <a:latin typeface="Helvetica Neue"/>
+                <a:ea typeface="Helvetica Neue"/>
+                <a:cs typeface="Helvetica Neue"/>
+              </a:rPr>
+              <a:t>Implement the bounded repair loop.</a:t>
             </a:r>
           </a:p>
         </p:txBody>

</xml_diff>